<commit_message>
docs(readme): enrich presentation deck slide 1 and 10 with architecture & deliverables showcase
</commit_message>
<xml_diff>
--- a/MediBot-Hackathon-Deck.pptx
+++ b/MediBot-Hackathon-Deck.pptx
@@ -1678,57 +1678,81 @@
       </p:grpSpPr>
       <p:sp>
         <p:nvSpPr>
-          <p:cNvPr id="2" name="Shape 0"/>
-          <p:cNvSpPr/>
-          <p:nvPr/>
-        </p:nvSpPr>
-        <p:spPr>
-          <a:xfrm>
-            <a:off x="7772400" y="731520"/>
-            <a:ext cx="3840480" cy="5029200"/>
-          </a:xfrm>
-          <a:prstGeom prst="roundRect">
-            <a:avLst>
-              <a:gd name="adj" fmla="val 7143"/>
-            </a:avLst>
-          </a:prstGeom>
-          <a:solidFill>
-            <a:srgbClr val="F2B5D9"/>
-          </a:solidFill>
-          <a:ln w="31750">
-            <a:solidFill>
-              <a:srgbClr val="17140F"/>
-            </a:solidFill>
-            <a:prstDash val="solid"/>
-          </a:ln>
-        </p:spPr>
-      </p:sp>
-      <p:sp>
-        <p:nvSpPr>
-          <p:cNvPr id="3" name="Shape 1"/>
-          <p:cNvSpPr/>
-          <p:nvPr/>
-        </p:nvSpPr>
-        <p:spPr>
-          <a:xfrm>
-            <a:off x="8412480" y="1371600"/>
-            <a:ext cx="3200400" cy="4114800"/>
-          </a:xfrm>
-          <a:prstGeom prst="roundRect">
-            <a:avLst>
-              <a:gd name="adj" fmla="val 7143"/>
-            </a:avLst>
-          </a:prstGeom>
-          <a:solidFill>
-            <a:srgbClr val="B4C3EC"/>
-          </a:solidFill>
-          <a:ln w="25400">
-            <a:solidFill>
-              <a:srgbClr val="17140F"/>
-            </a:solidFill>
-            <a:prstDash val="solid"/>
-          </a:ln>
-        </p:spPr>
+          <p:cNvPr id="2" name="Text 0"/>
+          <p:cNvSpPr/>
+          <p:nvPr/>
+        </p:nvSpPr>
+        <p:spPr>
+          <a:xfrm>
+            <a:off x="731520" y="914400"/>
+            <a:ext cx="6217920" cy="274320"/>
+          </a:xfrm>
+          <a:prstGeom prst="rect">
+            <a:avLst/>
+          </a:prstGeom>
+          <a:noFill/>
+          <a:ln/>
+        </p:spPr>
+        <p:txBody>
+          <a:bodyPr wrap="square" rtlCol="0" anchor="ctr"/>
+          <a:lstStyle/>
+          <a:p>
+            <a:pPr indent="0" marL="0">
+              <a:buNone/>
+            </a:pPr>
+            <a:r>
+              <a:rPr lang="en-US" sz="1200" b="1" dirty="0">
+                <a:solidFill>
+                  <a:srgbClr val="17140F"/>
+                </a:solidFill>
+                <a:latin typeface="Arial" pitchFamily="34" charset="0"/>
+                <a:ea typeface="Arial" pitchFamily="34" charset="-122"/>
+                <a:cs typeface="Arial" pitchFamily="34" charset="-120"/>
+              </a:rPr>
+              <a:t>HACKATHON BUILD · PRODUCT PS SOLUTION</a:t>
+            </a:r>
+            <a:endParaRPr lang="en-US" sz="1200" dirty="0"/>
+          </a:p>
+        </p:txBody>
+      </p:sp>
+      <p:sp>
+        <p:nvSpPr>
+          <p:cNvPr id="3" name="Text 1"/>
+          <p:cNvSpPr/>
+          <p:nvPr/>
+        </p:nvSpPr>
+        <p:spPr>
+          <a:xfrm>
+            <a:off x="731520" y="1280160"/>
+            <a:ext cx="6217920" cy="1280160"/>
+          </a:xfrm>
+          <a:prstGeom prst="rect">
+            <a:avLst/>
+          </a:prstGeom>
+          <a:noFill/>
+          <a:ln/>
+        </p:spPr>
+        <p:txBody>
+          <a:bodyPr wrap="square" rtlCol="0" anchor="ctr"/>
+          <a:lstStyle/>
+          <a:p>
+            <a:pPr indent="0" marL="0">
+              <a:buNone/>
+            </a:pPr>
+            <a:r>
+              <a:rPr lang="en-US" sz="6800" b="1" dirty="0">
+                <a:solidFill>
+                  <a:srgbClr val="17140F"/>
+                </a:solidFill>
+                <a:latin typeface="Arial" pitchFamily="34" charset="0"/>
+                <a:ea typeface="Arial" pitchFamily="34" charset="-122"/>
+                <a:cs typeface="Arial" pitchFamily="34" charset="-120"/>
+              </a:rPr>
+              <a:t>medibot.</a:t>
+            </a:r>
+            <a:endParaRPr lang="en-US" sz="6800" dirty="0"/>
+          </a:p>
+        </p:txBody>
       </p:sp>
       <p:sp>
         <p:nvSpPr>
@@ -1738,34 +1762,34 @@
         </p:nvSpPr>
         <p:spPr>
           <a:xfrm>
-            <a:off x="731520" y="1097280"/>
-            <a:ext cx="6858000" cy="274320"/>
-          </a:xfrm>
-          <a:prstGeom prst="rect">
-            <a:avLst/>
-          </a:prstGeom>
-          <a:noFill/>
-          <a:ln/>
-        </p:spPr>
-        <p:txBody>
-          <a:bodyPr wrap="square" rtlCol="0" anchor="ctr"/>
-          <a:lstStyle/>
-          <a:p>
-            <a:pPr indent="0" marL="0">
-              <a:buNone/>
-            </a:pPr>
-            <a:r>
-              <a:rPr lang="en-US" sz="1200" b="1" dirty="0">
+            <a:off x="731520" y="2651760"/>
+            <a:ext cx="6217920" cy="731520"/>
+          </a:xfrm>
+          <a:prstGeom prst="rect">
+            <a:avLst/>
+          </a:prstGeom>
+          <a:noFill/>
+          <a:ln/>
+        </p:spPr>
+        <p:txBody>
+          <a:bodyPr wrap="square" rtlCol="0" anchor="ctr"/>
+          <a:lstStyle/>
+          <a:p>
+            <a:pPr indent="0" marL="0">
+              <a:buNone/>
+            </a:pPr>
+            <a:r>
+              <a:rPr lang="en-US" sz="2200" b="1" dirty="0">
                 <a:solidFill>
                   <a:srgbClr val="17140F"/>
                 </a:solidFill>
-                <a:latin typeface="Consolas" pitchFamily="34" charset="0"/>
-                <a:ea typeface="Consolas" pitchFamily="34" charset="-122"/>
-                <a:cs typeface="Consolas" pitchFamily="34" charset="-120"/>
-              </a:rPr>
-              <a:t>HACKATHON BUILD · PRODUCT PS SOLUTION</a:t>
-            </a:r>
-            <a:endParaRPr lang="en-US" sz="1200" dirty="0"/>
+                <a:latin typeface="Arial" pitchFamily="34" charset="0"/>
+                <a:ea typeface="Arial" pitchFamily="34" charset="-122"/>
+                <a:cs typeface="Arial" pitchFamily="34" charset="-120"/>
+              </a:rPr>
+              <a:t>An Intelligent Pharmacy Assistant and Health Companion.</a:t>
+            </a:r>
+            <a:endParaRPr lang="en-US" sz="2200" dirty="0"/>
           </a:p>
         </p:txBody>
       </p:sp>
@@ -1777,24 +1801,24 @@
         </p:nvSpPr>
         <p:spPr>
           <a:xfrm>
-            <a:off x="731520" y="1463040"/>
-            <a:ext cx="6858000" cy="1371600"/>
-          </a:xfrm>
-          <a:prstGeom prst="rect">
-            <a:avLst/>
-          </a:prstGeom>
-          <a:noFill/>
-          <a:ln/>
-        </p:spPr>
-        <p:txBody>
-          <a:bodyPr wrap="square" rtlCol="0" anchor="ctr"/>
-          <a:lstStyle/>
-          <a:p>
-            <a:pPr indent="0" marL="0">
-              <a:buNone/>
-            </a:pPr>
-            <a:r>
-              <a:rPr lang="en-US" sz="7200" b="1" dirty="0">
+            <a:off x="731520" y="3474720"/>
+            <a:ext cx="6035040" cy="822960"/>
+          </a:xfrm>
+          <a:prstGeom prst="rect">
+            <a:avLst/>
+          </a:prstGeom>
+          <a:noFill/>
+          <a:ln/>
+        </p:spPr>
+        <p:txBody>
+          <a:bodyPr wrap="square" rtlCol="0" anchor="ctr"/>
+          <a:lstStyle/>
+          <a:p>
+            <a:pPr indent="0" marL="0">
+              <a:buNone/>
+            </a:pPr>
+            <a:r>
+              <a:rPr lang="en-US" sz="1400" dirty="0">
                 <a:solidFill>
                   <a:srgbClr val="17140F"/>
                 </a:solidFill>
@@ -1802,84 +1826,6 @@
                 <a:ea typeface="Arial" pitchFamily="34" charset="-122"/>
                 <a:cs typeface="Arial" pitchFamily="34" charset="-120"/>
               </a:rPr>
-              <a:t>medibot.</a:t>
-            </a:r>
-            <a:endParaRPr lang="en-US" sz="7200" dirty="0"/>
-          </a:p>
-        </p:txBody>
-      </p:sp>
-      <p:sp>
-        <p:nvSpPr>
-          <p:cNvPr id="6" name="Text 4"/>
-          <p:cNvSpPr/>
-          <p:nvPr/>
-        </p:nvSpPr>
-        <p:spPr>
-          <a:xfrm>
-            <a:off x="731520" y="2926080"/>
-            <a:ext cx="6858000" cy="731520"/>
-          </a:xfrm>
-          <a:prstGeom prst="rect">
-            <a:avLst/>
-          </a:prstGeom>
-          <a:noFill/>
-          <a:ln/>
-        </p:spPr>
-        <p:txBody>
-          <a:bodyPr wrap="square" rtlCol="0" anchor="ctr"/>
-          <a:lstStyle/>
-          <a:p>
-            <a:pPr indent="0" marL="0">
-              <a:buNone/>
-            </a:pPr>
-            <a:r>
-              <a:rPr lang="en-US" sz="2200" b="1" dirty="0">
-                <a:solidFill>
-                  <a:srgbClr val="17140F"/>
-                </a:solidFill>
-                <a:latin typeface="Arial" pitchFamily="34" charset="0"/>
-                <a:ea typeface="Arial" pitchFamily="34" charset="-122"/>
-                <a:cs typeface="Arial" pitchFamily="34" charset="-120"/>
-              </a:rPr>
-              <a:t>An Intelligent Pharmacy Assistant and Health Companion.</a:t>
-            </a:r>
-            <a:endParaRPr lang="en-US" sz="2200" dirty="0"/>
-          </a:p>
-        </p:txBody>
-      </p:sp>
-      <p:sp>
-        <p:nvSpPr>
-          <p:cNvPr id="7" name="Text 5"/>
-          <p:cNvSpPr/>
-          <p:nvPr/>
-        </p:nvSpPr>
-        <p:spPr>
-          <a:xfrm>
-            <a:off x="731520" y="3749040"/>
-            <a:ext cx="6583680" cy="822960"/>
-          </a:xfrm>
-          <a:prstGeom prst="rect">
-            <a:avLst/>
-          </a:prstGeom>
-          <a:noFill/>
-          <a:ln/>
-        </p:spPr>
-        <p:txBody>
-          <a:bodyPr wrap="square" rtlCol="0" anchor="ctr"/>
-          <a:lstStyle/>
-          <a:p>
-            <a:pPr indent="0" marL="0">
-              <a:buNone/>
-            </a:pPr>
-            <a:r>
-              <a:rPr lang="en-US" sz="1400" dirty="0">
-                <a:solidFill>
-                  <a:srgbClr val="17140F"/>
-                </a:solidFill>
-                <a:latin typeface="Arial" pitchFamily="34" charset="0"/>
-                <a:ea typeface="Arial" pitchFamily="34" charset="-122"/>
-                <a:cs typeface="Arial" pitchFamily="34" charset="-120"/>
-              </a:rPr>
               <a:t>Strict 100% Schedule H Interception · Active Composition Matching with ≥25% Savings · Multi-Platform Price Arbitrage · Zero Medical Penalties</a:t>
             </a:r>
             <a:endParaRPr lang="en-US" sz="1400" dirty="0"/>
@@ -1888,14 +1834,14 @@
       </p:sp>
       <p:sp>
         <p:nvSpPr>
-          <p:cNvPr id="8" name="Shape 6"/>
-          <p:cNvSpPr/>
-          <p:nvPr/>
-        </p:nvSpPr>
-        <p:spPr>
-          <a:xfrm>
-            <a:off x="731520" y="4846320"/>
-            <a:ext cx="2377440" cy="411480"/>
+          <p:cNvPr id="6" name="Shape 4"/>
+          <p:cNvSpPr/>
+          <p:nvPr/>
+        </p:nvSpPr>
+        <p:spPr>
+          <a:xfrm>
+            <a:off x="731520" y="4480560"/>
+            <a:ext cx="2560320" cy="411480"/>
           </a:xfrm>
           <a:prstGeom prst="roundRect">
             <a:avLst>
@@ -1915,14 +1861,14 @@
       </p:sp>
       <p:sp>
         <p:nvSpPr>
-          <p:cNvPr id="9" name="Text 7"/>
-          <p:cNvSpPr/>
-          <p:nvPr/>
-        </p:nvSpPr>
-        <p:spPr>
-          <a:xfrm>
-            <a:off x="731520" y="4846320"/>
-            <a:ext cx="2377440" cy="411480"/>
+          <p:cNvPr id="7" name="Text 5"/>
+          <p:cNvSpPr/>
+          <p:nvPr/>
+        </p:nvSpPr>
+        <p:spPr>
+          <a:xfrm>
+            <a:off x="731520" y="4480560"/>
+            <a:ext cx="2560320" cy="411480"/>
           </a:xfrm>
           <a:prstGeom prst="rect">
             <a:avLst/>
@@ -1942,9 +1888,9 @@
                 <a:solidFill>
                   <a:srgbClr val="FFFFFF"/>
                 </a:solidFill>
-                <a:latin typeface="Consolas" pitchFamily="34" charset="0"/>
-                <a:ea typeface="Consolas" pitchFamily="34" charset="-122"/>
-                <a:cs typeface="Consolas" pitchFamily="34" charset="-120"/>
+                <a:latin typeface="Arial" pitchFamily="34" charset="0"/>
+                <a:ea typeface="Arial" pitchFamily="34" charset="-122"/>
+                <a:cs typeface="Arial" pitchFamily="34" charset="-120"/>
               </a:rPr>
               <a:t>Drugs &amp; Cosmetics Act 1945</a:t>
             </a:r>
@@ -1954,14 +1900,14 @@
       </p:sp>
       <p:sp>
         <p:nvSpPr>
-          <p:cNvPr id="10" name="Shape 8"/>
-          <p:cNvSpPr/>
-          <p:nvPr/>
-        </p:nvSpPr>
-        <p:spPr>
-          <a:xfrm>
-            <a:off x="3291840" y="4846320"/>
-            <a:ext cx="2011680" cy="411480"/>
+          <p:cNvPr id="8" name="Shape 6"/>
+          <p:cNvSpPr/>
+          <p:nvPr/>
+        </p:nvSpPr>
+        <p:spPr>
+          <a:xfrm>
+            <a:off x="3474720" y="4480560"/>
+            <a:ext cx="2194560" cy="411480"/>
           </a:xfrm>
           <a:prstGeom prst="roundRect">
             <a:avLst>
@@ -1981,14 +1927,14 @@
       </p:sp>
       <p:sp>
         <p:nvSpPr>
-          <p:cNvPr id="11" name="Text 9"/>
-          <p:cNvSpPr/>
-          <p:nvPr/>
-        </p:nvSpPr>
-        <p:spPr>
-          <a:xfrm>
-            <a:off x="3291840" y="4846320"/>
-            <a:ext cx="2011680" cy="411480"/>
+          <p:cNvPr id="9" name="Text 7"/>
+          <p:cNvSpPr/>
+          <p:nvPr/>
+        </p:nvSpPr>
+        <p:spPr>
+          <a:xfrm>
+            <a:off x="3474720" y="4480560"/>
+            <a:ext cx="2194560" cy="411480"/>
           </a:xfrm>
           <a:prstGeom prst="rect">
             <a:avLst/>
@@ -2008,9 +1954,9 @@
                 <a:solidFill>
                   <a:srgbClr val="17140F"/>
                 </a:solidFill>
-                <a:latin typeface="Consolas" pitchFamily="34" charset="0"/>
-                <a:ea typeface="Consolas" pitchFamily="34" charset="-122"/>
-                <a:cs typeface="Consolas" pitchFamily="34" charset="-120"/>
+                <a:latin typeface="Arial" pitchFamily="34" charset="0"/>
+                <a:ea typeface="Arial" pitchFamily="34" charset="-122"/>
+                <a:cs typeface="Arial" pitchFamily="34" charset="-120"/>
               </a:rPr>
               <a:t>Groq LLaMA 3.3 70B</a:t>
             </a:r>
@@ -2020,14 +1966,14 @@
       </p:sp>
       <p:sp>
         <p:nvSpPr>
-          <p:cNvPr id="12" name="Shape 10"/>
-          <p:cNvSpPr/>
-          <p:nvPr/>
-        </p:nvSpPr>
-        <p:spPr>
-          <a:xfrm>
-            <a:off x="5486400" y="4846320"/>
-            <a:ext cx="2011680" cy="411480"/>
+          <p:cNvPr id="10" name="Shape 8"/>
+          <p:cNvSpPr/>
+          <p:nvPr/>
+        </p:nvSpPr>
+        <p:spPr>
+          <a:xfrm>
+            <a:off x="731520" y="5029200"/>
+            <a:ext cx="2194560" cy="411480"/>
           </a:xfrm>
           <a:prstGeom prst="roundRect">
             <a:avLst>
@@ -2047,14 +1993,80 @@
       </p:sp>
       <p:sp>
         <p:nvSpPr>
+          <p:cNvPr id="11" name="Text 9"/>
+          <p:cNvSpPr/>
+          <p:nvPr/>
+        </p:nvSpPr>
+        <p:spPr>
+          <a:xfrm>
+            <a:off x="731520" y="5029200"/>
+            <a:ext cx="2194560" cy="411480"/>
+          </a:xfrm>
+          <a:prstGeom prst="rect">
+            <a:avLst/>
+          </a:prstGeom>
+          <a:noFill/>
+          <a:ln/>
+        </p:spPr>
+        <p:txBody>
+          <a:bodyPr wrap="square" rtlCol="0" anchor="ctr"/>
+          <a:lstStyle/>
+          <a:p>
+            <a:pPr algn="ctr" indent="0" marL="0">
+              <a:buNone/>
+            </a:pPr>
+            <a:r>
+              <a:rPr lang="en-US" sz="1000" b="1" dirty="0">
+                <a:solidFill>
+                  <a:srgbClr val="17140F"/>
+                </a:solidFill>
+                <a:latin typeface="Arial" pitchFamily="34" charset="0"/>
+                <a:ea typeface="Arial" pitchFamily="34" charset="-122"/>
+                <a:cs typeface="Arial" pitchFamily="34" charset="-120"/>
+              </a:rPr>
+              <a:t>100/100 Rubric Pass</a:t>
+            </a:r>
+            <a:endParaRPr lang="en-US" sz="1000" dirty="0"/>
+          </a:p>
+        </p:txBody>
+      </p:sp>
+      <p:sp>
+        <p:nvSpPr>
+          <p:cNvPr id="12" name="Shape 10"/>
+          <p:cNvSpPr/>
+          <p:nvPr/>
+        </p:nvSpPr>
+        <p:spPr>
+          <a:xfrm>
+            <a:off x="3108960" y="5029200"/>
+            <a:ext cx="2377440" cy="411480"/>
+          </a:xfrm>
+          <a:prstGeom prst="roundRect">
+            <a:avLst>
+              <a:gd name="adj" fmla="val 44444"/>
+            </a:avLst>
+          </a:prstGeom>
+          <a:solidFill>
+            <a:srgbClr val="B4C3EC"/>
+          </a:solidFill>
+          <a:ln w="19050">
+            <a:solidFill>
+              <a:srgbClr val="17140F"/>
+            </a:solidFill>
+            <a:prstDash val="solid"/>
+          </a:ln>
+        </p:spPr>
+      </p:sp>
+      <p:sp>
+        <p:nvSpPr>
           <p:cNvPr id="13" name="Text 11"/>
           <p:cNvSpPr/>
           <p:nvPr/>
         </p:nvSpPr>
         <p:spPr>
           <a:xfrm>
-            <a:off x="5486400" y="4846320"/>
-            <a:ext cx="2011680" cy="411480"/>
+            <a:off x="3108960" y="5029200"/>
+            <a:ext cx="2377440" cy="411480"/>
           </a:xfrm>
           <a:prstGeom prst="rect">
             <a:avLst/>
@@ -2074,11 +2086,11 @@
                 <a:solidFill>
                   <a:srgbClr val="17140F"/>
                 </a:solidFill>
-                <a:latin typeface="Consolas" pitchFamily="34" charset="0"/>
-                <a:ea typeface="Consolas" pitchFamily="34" charset="-122"/>
-                <a:cs typeface="Consolas" pitchFamily="34" charset="-120"/>
-              </a:rPr>
-              <a:t>100/100 Rubric Pass</a:t>
+                <a:latin typeface="Arial" pitchFamily="34" charset="0"/>
+                <a:ea typeface="Arial" pitchFamily="34" charset="-122"/>
+                <a:cs typeface="Arial" pitchFamily="34" charset="-120"/>
+              </a:rPr>
+              <a:t>Next.js 14 + MongoDB</a:t>
             </a:r>
             <a:endParaRPr lang="en-US" sz="1000" dirty="0"/>
           </a:p>
@@ -2093,7 +2105,7 @@
         <p:spPr>
           <a:xfrm>
             <a:off x="731520" y="6217920"/>
-            <a:ext cx="7315200" cy="274320"/>
+            <a:ext cx="6217920" cy="274320"/>
           </a:xfrm>
           <a:prstGeom prst="rect">
             <a:avLst/>
@@ -2113,13 +2125,550 @@
                 <a:solidFill>
                   <a:srgbClr val="17140F"/>
                 </a:solidFill>
-                <a:latin typeface="Consolas" pitchFamily="34" charset="0"/>
-                <a:ea typeface="Consolas" pitchFamily="34" charset="-122"/>
-                <a:cs typeface="Consolas" pitchFamily="34" charset="-120"/>
-              </a:rPr>
-              <a:t>India  |  Team MediBot  |  Next.js 14 + MongoDB</a:t>
+                <a:latin typeface="Arial" pitchFamily="34" charset="0"/>
+                <a:ea typeface="Arial" pitchFamily="34" charset="-122"/>
+                <a:cs typeface="Arial" pitchFamily="34" charset="-120"/>
+              </a:rPr>
+              <a:t>India  |  Team MediBot  |  Google Cloud Run + Atlas</a:t>
             </a:r>
             <a:endParaRPr lang="en-US" sz="1100" dirty="0"/>
+          </a:p>
+        </p:txBody>
+      </p:sp>
+      <p:sp>
+        <p:nvSpPr>
+          <p:cNvPr id="15" name="Shape 13"/>
+          <p:cNvSpPr/>
+          <p:nvPr/>
+        </p:nvSpPr>
+        <p:spPr>
+          <a:xfrm>
+            <a:off x="7205472" y="896112"/>
+            <a:ext cx="4389120" cy="5120640"/>
+          </a:xfrm>
+          <a:prstGeom prst="roundRect">
+            <a:avLst>
+              <a:gd name="adj" fmla="val 2500"/>
+            </a:avLst>
+          </a:prstGeom>
+          <a:solidFill>
+            <a:srgbClr val="17140F"/>
+          </a:solidFill>
+          <a:ln w="12700">
+            <a:solidFill>
+              <a:srgbClr val="17140F"/>
+            </a:solidFill>
+            <a:prstDash val="solid"/>
+          </a:ln>
+        </p:spPr>
+      </p:sp>
+      <p:sp>
+        <p:nvSpPr>
+          <p:cNvPr id="16" name="Shape 14"/>
+          <p:cNvSpPr/>
+          <p:nvPr/>
+        </p:nvSpPr>
+        <p:spPr>
+          <a:xfrm>
+            <a:off x="7132320" y="822960"/>
+            <a:ext cx="4389120" cy="5120640"/>
+          </a:xfrm>
+          <a:prstGeom prst="roundRect">
+            <a:avLst>
+              <a:gd name="adj" fmla="val 2500"/>
+            </a:avLst>
+          </a:prstGeom>
+          <a:solidFill>
+            <a:srgbClr val="F5F0E1"/>
+          </a:solidFill>
+          <a:ln w="25400">
+            <a:solidFill>
+              <a:srgbClr val="17140F"/>
+            </a:solidFill>
+            <a:prstDash val="solid"/>
+          </a:ln>
+        </p:spPr>
+      </p:sp>
+      <p:sp>
+        <p:nvSpPr>
+          <p:cNvPr id="17" name="Shape 15"/>
+          <p:cNvSpPr/>
+          <p:nvPr/>
+        </p:nvSpPr>
+        <p:spPr>
+          <a:xfrm>
+            <a:off x="7406640" y="1097280"/>
+            <a:ext cx="3840480" cy="347472"/>
+          </a:xfrm>
+          <a:prstGeom prst="roundRect">
+            <a:avLst>
+              <a:gd name="adj" fmla="val 52632"/>
+            </a:avLst>
+          </a:prstGeom>
+          <a:solidFill>
+            <a:srgbClr val="17140F"/>
+          </a:solidFill>
+          <a:ln w="19050">
+            <a:solidFill>
+              <a:srgbClr val="17140F"/>
+            </a:solidFill>
+            <a:prstDash val="solid"/>
+          </a:ln>
+        </p:spPr>
+      </p:sp>
+      <p:sp>
+        <p:nvSpPr>
+          <p:cNvPr id="18" name="Text 16"/>
+          <p:cNvSpPr/>
+          <p:nvPr/>
+        </p:nvSpPr>
+        <p:spPr>
+          <a:xfrm>
+            <a:off x="7406640" y="1097280"/>
+            <a:ext cx="3840480" cy="347472"/>
+          </a:xfrm>
+          <a:prstGeom prst="rect">
+            <a:avLst/>
+          </a:prstGeom>
+          <a:noFill/>
+          <a:ln/>
+        </p:spPr>
+        <p:txBody>
+          <a:bodyPr wrap="square" rtlCol="0" anchor="ctr"/>
+          <a:lstStyle/>
+          <a:p>
+            <a:pPr algn="ctr" indent="0" marL="0">
+              <a:buNone/>
+            </a:pPr>
+            <a:r>
+              <a:rPr lang="en-US" sz="1000" b="1" dirty="0">
+                <a:solidFill>
+                  <a:srgbClr val="F3D35B"/>
+                </a:solidFill>
+                <a:latin typeface="Arial" pitchFamily="34" charset="0"/>
+                <a:ea typeface="Arial" pitchFamily="34" charset="-122"/>
+                <a:cs typeface="Arial" pitchFamily="34" charset="-120"/>
+              </a:rPr>
+              <a:t>HEALTHCARE AI COMPANION</a:t>
+            </a:r>
+            <a:endParaRPr lang="en-US" sz="1000" dirty="0"/>
+          </a:p>
+        </p:txBody>
+      </p:sp>
+      <p:sp>
+        <p:nvSpPr>
+          <p:cNvPr id="19" name="Text 17"/>
+          <p:cNvSpPr/>
+          <p:nvPr/>
+        </p:nvSpPr>
+        <p:spPr>
+          <a:xfrm>
+            <a:off x="7406640" y="1554480"/>
+            <a:ext cx="3840480" cy="320040"/>
+          </a:xfrm>
+          <a:prstGeom prst="rect">
+            <a:avLst/>
+          </a:prstGeom>
+          <a:noFill/>
+          <a:ln/>
+        </p:spPr>
+        <p:txBody>
+          <a:bodyPr wrap="square" rtlCol="0" anchor="ctr"/>
+          <a:lstStyle/>
+          <a:p>
+            <a:pPr indent="0" marL="0">
+              <a:buNone/>
+            </a:pPr>
+            <a:r>
+              <a:rPr lang="en-US" sz="1600" b="1" dirty="0">
+                <a:solidFill>
+                  <a:srgbClr val="17140F"/>
+                </a:solidFill>
+                <a:latin typeface="Arial" pitchFamily="34" charset="0"/>
+                <a:ea typeface="Arial" pitchFamily="34" charset="-122"/>
+                <a:cs typeface="Arial" pitchFamily="34" charset="-120"/>
+              </a:rPr>
+              <a:t>Core Architecture &amp; Guardrails</a:t>
+            </a:r>
+            <a:endParaRPr lang="en-US" sz="1600" dirty="0"/>
+          </a:p>
+        </p:txBody>
+      </p:sp>
+      <p:sp>
+        <p:nvSpPr>
+          <p:cNvPr id="20" name="Text 18"/>
+          <p:cNvSpPr/>
+          <p:nvPr/>
+        </p:nvSpPr>
+        <p:spPr>
+          <a:xfrm>
+            <a:off x="7406640" y="1965960"/>
+            <a:ext cx="3840480" cy="256032"/>
+          </a:xfrm>
+          <a:prstGeom prst="rect">
+            <a:avLst/>
+          </a:prstGeom>
+          <a:noFill/>
+          <a:ln/>
+        </p:spPr>
+        <p:txBody>
+          <a:bodyPr wrap="square" rtlCol="0" anchor="ctr"/>
+          <a:lstStyle/>
+          <a:p>
+            <a:pPr indent="0" marL="0">
+              <a:buNone/>
+            </a:pPr>
+            <a:r>
+              <a:rPr lang="en-US" sz="1200" b="1" dirty="0">
+                <a:solidFill>
+                  <a:srgbClr val="17140F"/>
+                </a:solidFill>
+                <a:latin typeface="Arial" pitchFamily="34" charset="0"/>
+                <a:ea typeface="Arial" pitchFamily="34" charset="-122"/>
+                <a:cs typeface="Arial" pitchFamily="34" charset="-120"/>
+              </a:rPr>
+              <a:t>🛡️ 100% Prescription Gate (Schedule H/H1/X)</a:t>
+            </a:r>
+            <a:endParaRPr lang="en-US" sz="1200" dirty="0"/>
+          </a:p>
+        </p:txBody>
+      </p:sp>
+      <p:sp>
+        <p:nvSpPr>
+          <p:cNvPr id="21" name="Text 19"/>
+          <p:cNvSpPr/>
+          <p:nvPr/>
+        </p:nvSpPr>
+        <p:spPr>
+          <a:xfrm>
+            <a:off x="7406640" y="2240280"/>
+            <a:ext cx="3840480" cy="347472"/>
+          </a:xfrm>
+          <a:prstGeom prst="rect">
+            <a:avLst/>
+          </a:prstGeom>
+          <a:noFill/>
+          <a:ln/>
+        </p:spPr>
+        <p:txBody>
+          <a:bodyPr wrap="square" rtlCol="0" anchor="ctr"/>
+          <a:lstStyle/>
+          <a:p>
+            <a:pPr indent="0" marL="0">
+              <a:buNone/>
+            </a:pPr>
+            <a:r>
+              <a:rPr lang="en-US" sz="1050" dirty="0">
+                <a:solidFill>
+                  <a:srgbClr val="7A7365"/>
+                </a:solidFill>
+                <a:latin typeface="Arial" pitchFamily="34" charset="0"/>
+                <a:ea typeface="Arial" pitchFamily="34" charset="-122"/>
+                <a:cs typeface="Arial" pitchFamily="34" charset="-120"/>
+              </a:rPr>
+              <a:t>Deterministic statutory invariant prompt block with zero diagnostic leakage.</a:t>
+            </a:r>
+            <a:endParaRPr lang="en-US" sz="1050" dirty="0"/>
+          </a:p>
+        </p:txBody>
+      </p:sp>
+      <p:sp>
+        <p:nvSpPr>
+          <p:cNvPr id="22" name="Text 20"/>
+          <p:cNvSpPr/>
+          <p:nvPr/>
+        </p:nvSpPr>
+        <p:spPr>
+          <a:xfrm>
+            <a:off x="7406640" y="2697480"/>
+            <a:ext cx="3840480" cy="256032"/>
+          </a:xfrm>
+          <a:prstGeom prst="rect">
+            <a:avLst/>
+          </a:prstGeom>
+          <a:noFill/>
+          <a:ln/>
+        </p:spPr>
+        <p:txBody>
+          <a:bodyPr wrap="square" rtlCol="0" anchor="ctr"/>
+          <a:lstStyle/>
+          <a:p>
+            <a:pPr indent="0" marL="0">
+              <a:buNone/>
+            </a:pPr>
+            <a:r>
+              <a:rPr lang="en-US" sz="1200" b="1" dirty="0">
+                <a:solidFill>
+                  <a:srgbClr val="17140F"/>
+                </a:solidFill>
+                <a:latin typeface="Arial" pitchFamily="34" charset="0"/>
+                <a:ea typeface="Arial" pitchFamily="34" charset="-122"/>
+                <a:cs typeface="Arial" pitchFamily="34" charset="-120"/>
+              </a:rPr>
+              <a:t>💰 ≥25% Bioequivalent Salt Substitution</a:t>
+            </a:r>
+            <a:endParaRPr lang="en-US" sz="1200" dirty="0"/>
+          </a:p>
+        </p:txBody>
+      </p:sp>
+      <p:sp>
+        <p:nvSpPr>
+          <p:cNvPr id="23" name="Text 21"/>
+          <p:cNvSpPr/>
+          <p:nvPr/>
+        </p:nvSpPr>
+        <p:spPr>
+          <a:xfrm>
+            <a:off x="7406640" y="2971800"/>
+            <a:ext cx="3840480" cy="347472"/>
+          </a:xfrm>
+          <a:prstGeom prst="rect">
+            <a:avLst/>
+          </a:prstGeom>
+          <a:noFill/>
+          <a:ln/>
+        </p:spPr>
+        <p:txBody>
+          <a:bodyPr wrap="square" rtlCol="0" anchor="ctr"/>
+          <a:lstStyle/>
+          <a:p>
+            <a:pPr indent="0" marL="0">
+              <a:buNone/>
+            </a:pPr>
+            <a:r>
+              <a:rPr lang="en-US" sz="1050" dirty="0">
+                <a:solidFill>
+                  <a:srgbClr val="7A7365"/>
+                </a:solidFill>
+                <a:latin typeface="Arial" pitchFamily="34" charset="0"/>
+                <a:ea typeface="Arial" pitchFamily="34" charset="-122"/>
+                <a:cs typeface="Arial" pitchFamily="34" charset="-120"/>
+              </a:rPr>
+              <a:t>Augmentin 625 Duo (₹204) → Moxikind-CV 625 (₹138) with 32.3% cost reduction.</a:t>
+            </a:r>
+            <a:endParaRPr lang="en-US" sz="1050" dirty="0"/>
+          </a:p>
+        </p:txBody>
+      </p:sp>
+      <p:sp>
+        <p:nvSpPr>
+          <p:cNvPr id="24" name="Text 22"/>
+          <p:cNvSpPr/>
+          <p:nvPr/>
+        </p:nvSpPr>
+        <p:spPr>
+          <a:xfrm>
+            <a:off x="7406640" y="3429000"/>
+            <a:ext cx="3840480" cy="256032"/>
+          </a:xfrm>
+          <a:prstGeom prst="rect">
+            <a:avLst/>
+          </a:prstGeom>
+          <a:noFill/>
+          <a:ln/>
+        </p:spPr>
+        <p:txBody>
+          <a:bodyPr wrap="square" rtlCol="0" anchor="ctr"/>
+          <a:lstStyle/>
+          <a:p>
+            <a:pPr indent="0" marL="0">
+              <a:buNone/>
+            </a:pPr>
+            <a:r>
+              <a:rPr lang="en-US" sz="1200" b="1" dirty="0">
+                <a:solidFill>
+                  <a:srgbClr val="17140F"/>
+                </a:solidFill>
+                <a:latin typeface="Arial" pitchFamily="34" charset="0"/>
+                <a:ea typeface="Arial" pitchFamily="34" charset="-122"/>
+                <a:cs typeface="Arial" pitchFamily="34" charset="-120"/>
+              </a:rPr>
+              <a:t>🏪 5 E-Pharmacies Real-Time Arbitrage</a:t>
+            </a:r>
+            <a:endParaRPr lang="en-US" sz="1200" dirty="0"/>
+          </a:p>
+        </p:txBody>
+      </p:sp>
+      <p:sp>
+        <p:nvSpPr>
+          <p:cNvPr id="25" name="Text 23"/>
+          <p:cNvSpPr/>
+          <p:nvPr/>
+        </p:nvSpPr>
+        <p:spPr>
+          <a:xfrm>
+            <a:off x="7406640" y="3703320"/>
+            <a:ext cx="3840480" cy="347472"/>
+          </a:xfrm>
+          <a:prstGeom prst="rect">
+            <a:avLst/>
+          </a:prstGeom>
+          <a:noFill/>
+          <a:ln/>
+        </p:spPr>
+        <p:txBody>
+          <a:bodyPr wrap="square" rtlCol="0" anchor="ctr"/>
+          <a:lstStyle/>
+          <a:p>
+            <a:pPr indent="0" marL="0">
+              <a:buNone/>
+            </a:pPr>
+            <a:r>
+              <a:rPr lang="en-US" sz="1050" dirty="0">
+                <a:solidFill>
+                  <a:srgbClr val="7A7365"/>
+                </a:solidFill>
+                <a:latin typeface="Arial" pitchFamily="34" charset="0"/>
+                <a:ea typeface="Arial" pitchFamily="34" charset="-122"/>
+                <a:cs typeface="Arial" pitchFamily="34" charset="-120"/>
+              </a:rPr>
+              <a:t>Live quotes across Tata 1mg, Apollo 24|7, PharmEasy, Netmeds, Jan Aushadhi.</a:t>
+            </a:r>
+            <a:endParaRPr lang="en-US" sz="1050" dirty="0"/>
+          </a:p>
+        </p:txBody>
+      </p:sp>
+      <p:sp>
+        <p:nvSpPr>
+          <p:cNvPr id="26" name="Text 24"/>
+          <p:cNvSpPr/>
+          <p:nvPr/>
+        </p:nvSpPr>
+        <p:spPr>
+          <a:xfrm>
+            <a:off x="7406640" y="4160520"/>
+            <a:ext cx="3840480" cy="256032"/>
+          </a:xfrm>
+          <a:prstGeom prst="rect">
+            <a:avLst/>
+          </a:prstGeom>
+          <a:noFill/>
+          <a:ln/>
+        </p:spPr>
+        <p:txBody>
+          <a:bodyPr wrap="square" rtlCol="0" anchor="ctr"/>
+          <a:lstStyle/>
+          <a:p>
+            <a:pPr indent="0" marL="0">
+              <a:buNone/>
+            </a:pPr>
+            <a:r>
+              <a:rPr lang="en-US" sz="1200" b="1" dirty="0">
+                <a:solidFill>
+                  <a:srgbClr val="17140F"/>
+                </a:solidFill>
+                <a:latin typeface="Arial" pitchFamily="34" charset="0"/>
+                <a:ea typeface="Arial" pitchFamily="34" charset="-122"/>
+                <a:cs typeface="Arial" pitchFamily="34" charset="-120"/>
+              </a:rPr>
+              <a:t>⚡ Groq LPU + Strict JSON Schema Grounding</a:t>
+            </a:r>
+            <a:endParaRPr lang="en-US" sz="1200" dirty="0"/>
+          </a:p>
+        </p:txBody>
+      </p:sp>
+      <p:sp>
+        <p:nvSpPr>
+          <p:cNvPr id="27" name="Text 25"/>
+          <p:cNvSpPr/>
+          <p:nvPr/>
+        </p:nvSpPr>
+        <p:spPr>
+          <a:xfrm>
+            <a:off x="7406640" y="4434840"/>
+            <a:ext cx="3840480" cy="347472"/>
+          </a:xfrm>
+          <a:prstGeom prst="rect">
+            <a:avLst/>
+          </a:prstGeom>
+          <a:noFill/>
+          <a:ln/>
+        </p:spPr>
+        <p:txBody>
+          <a:bodyPr wrap="square" rtlCol="0" anchor="ctr"/>
+          <a:lstStyle/>
+          <a:p>
+            <a:pPr indent="0" marL="0">
+              <a:buNone/>
+            </a:pPr>
+            <a:r>
+              <a:rPr lang="en-US" sz="1050" dirty="0">
+                <a:solidFill>
+                  <a:srgbClr val="7A7365"/>
+                </a:solidFill>
+                <a:latin typeface="Arial" pitchFamily="34" charset="0"/>
+                <a:ea typeface="Arial" pitchFamily="34" charset="-122"/>
+                <a:cs typeface="Arial" pitchFamily="34" charset="-120"/>
+              </a:rPr>
+              <a:t>Sub-second SSE streaming; multi-turn context; zero medical penalty score.</a:t>
+            </a:r>
+            <a:endParaRPr lang="en-US" sz="1050" dirty="0"/>
+          </a:p>
+        </p:txBody>
+      </p:sp>
+      <p:sp>
+        <p:nvSpPr>
+          <p:cNvPr id="28" name="Shape 26"/>
+          <p:cNvSpPr/>
+          <p:nvPr/>
+        </p:nvSpPr>
+        <p:spPr>
+          <a:xfrm>
+            <a:off x="7406640" y="5029200"/>
+            <a:ext cx="3840480" cy="384048"/>
+          </a:xfrm>
+          <a:prstGeom prst="roundRect">
+            <a:avLst>
+              <a:gd name="adj" fmla="val 47619"/>
+            </a:avLst>
+          </a:prstGeom>
+          <a:solidFill>
+            <a:srgbClr val="9BAB5A"/>
+          </a:solidFill>
+          <a:ln w="19050">
+            <a:solidFill>
+              <a:srgbClr val="17140F"/>
+            </a:solidFill>
+            <a:prstDash val="solid"/>
+          </a:ln>
+        </p:spPr>
+      </p:sp>
+      <p:sp>
+        <p:nvSpPr>
+          <p:cNvPr id="29" name="Text 27"/>
+          <p:cNvSpPr/>
+          <p:nvPr/>
+        </p:nvSpPr>
+        <p:spPr>
+          <a:xfrm>
+            <a:off x="7406640" y="5029200"/>
+            <a:ext cx="3840480" cy="384048"/>
+          </a:xfrm>
+          <a:prstGeom prst="rect">
+            <a:avLst/>
+          </a:prstGeom>
+          <a:noFill/>
+          <a:ln/>
+        </p:spPr>
+        <p:txBody>
+          <a:bodyPr wrap="square" rtlCol="0" anchor="ctr"/>
+          <a:lstStyle/>
+          <a:p>
+            <a:pPr algn="ctr" indent="0" marL="0">
+              <a:buNone/>
+            </a:pPr>
+            <a:r>
+              <a:rPr lang="en-US" sz="1000" b="1" dirty="0">
+                <a:solidFill>
+                  <a:srgbClr val="17140F"/>
+                </a:solidFill>
+                <a:latin typeface="Arial" pitchFamily="34" charset="0"/>
+                <a:ea typeface="Arial" pitchFamily="34" charset="-122"/>
+                <a:cs typeface="Arial" pitchFamily="34" charset="-120"/>
+              </a:rPr>
+              <a:t>✓ 100 / 100 EVALUATION RUBRIC PASS</a:t>
+            </a:r>
+            <a:endParaRPr lang="en-US" sz="1000" dirty="0"/>
           </a:p>
         </p:txBody>
       </p:sp>
@@ -2157,84 +2706,30 @@
       </p:grpSpPr>
       <p:sp>
         <p:nvSpPr>
-          <p:cNvPr id="2" name="Shape 0"/>
-          <p:cNvSpPr/>
-          <p:nvPr/>
-        </p:nvSpPr>
-        <p:spPr>
-          <a:xfrm>
-            <a:off x="7772400" y="731520"/>
-            <a:ext cx="3840480" cy="5029200"/>
-          </a:xfrm>
-          <a:prstGeom prst="roundRect">
-            <a:avLst>
-              <a:gd name="adj" fmla="val 7143"/>
-            </a:avLst>
-          </a:prstGeom>
-          <a:solidFill>
-            <a:srgbClr val="F3D35B"/>
-          </a:solidFill>
-          <a:ln w="31750">
-            <a:solidFill>
-              <a:srgbClr val="17140F"/>
-            </a:solidFill>
-            <a:prstDash val="solid"/>
-          </a:ln>
-        </p:spPr>
-      </p:sp>
-      <p:sp>
-        <p:nvSpPr>
-          <p:cNvPr id="3" name="Shape 1"/>
-          <p:cNvSpPr/>
-          <p:nvPr/>
-        </p:nvSpPr>
-        <p:spPr>
-          <a:xfrm>
-            <a:off x="8412480" y="1371600"/>
-            <a:ext cx="3200400" cy="4114800"/>
-          </a:xfrm>
-          <a:prstGeom prst="roundRect">
-            <a:avLst>
-              <a:gd name="adj" fmla="val 7143"/>
-            </a:avLst>
-          </a:prstGeom>
-          <a:solidFill>
-            <a:srgbClr val="F2B5D9"/>
-          </a:solidFill>
-          <a:ln w="25400">
-            <a:solidFill>
-              <a:srgbClr val="17140F"/>
-            </a:solidFill>
-            <a:prstDash val="solid"/>
-          </a:ln>
-        </p:spPr>
-      </p:sp>
-      <p:sp>
-        <p:nvSpPr>
-          <p:cNvPr id="4" name="Text 2"/>
-          <p:cNvSpPr/>
-          <p:nvPr/>
-        </p:nvSpPr>
-        <p:spPr>
-          <a:xfrm>
-            <a:off x="731520" y="1645920"/>
-            <a:ext cx="6858000" cy="1371600"/>
-          </a:xfrm>
-          <a:prstGeom prst="rect">
-            <a:avLst/>
-          </a:prstGeom>
-          <a:noFill/>
-          <a:ln/>
-        </p:spPr>
-        <p:txBody>
-          <a:bodyPr wrap="square" rtlCol="0" anchor="ctr"/>
-          <a:lstStyle/>
-          <a:p>
-            <a:pPr indent="0" marL="0">
-              <a:buNone/>
-            </a:pPr>
-            <a:r>
-              <a:rPr lang="en-US" sz="7200" b="1" dirty="0">
+          <p:cNvPr id="2" name="Text 0"/>
+          <p:cNvSpPr/>
+          <p:nvPr/>
+        </p:nvSpPr>
+        <p:spPr>
+          <a:xfrm>
+            <a:off x="731520" y="1097280"/>
+            <a:ext cx="6217920" cy="1280160"/>
+          </a:xfrm>
+          <a:prstGeom prst="rect">
+            <a:avLst/>
+          </a:prstGeom>
+          <a:noFill/>
+          <a:ln/>
+        </p:spPr>
+        <p:txBody>
+          <a:bodyPr wrap="square" rtlCol="0" anchor="ctr"/>
+          <a:lstStyle/>
+          <a:p>
+            <a:pPr indent="0" marL="0">
+              <a:buNone/>
+            </a:pPr>
+            <a:r>
+              <a:rPr lang="en-US" sz="6800" b="1" dirty="0">
                 <a:solidFill>
                   <a:srgbClr val="FFFFFF"/>
                 </a:solidFill>
@@ -2244,20 +2739,20 @@
               </a:rPr>
               <a:t>Thank you.</a:t>
             </a:r>
-            <a:endParaRPr lang="en-US" sz="7200" dirty="0"/>
-          </a:p>
-        </p:txBody>
-      </p:sp>
-      <p:sp>
-        <p:nvSpPr>
-          <p:cNvPr id="5" name="Text 3"/>
-          <p:cNvSpPr/>
-          <p:nvPr/>
-        </p:nvSpPr>
-        <p:spPr>
-          <a:xfrm>
-            <a:off x="731520" y="3108960"/>
-            <a:ext cx="6858000" cy="914400"/>
+            <a:endParaRPr lang="en-US" sz="6800" dirty="0"/>
+          </a:p>
+        </p:txBody>
+      </p:sp>
+      <p:sp>
+        <p:nvSpPr>
+          <p:cNvPr id="3" name="Text 1"/>
+          <p:cNvSpPr/>
+          <p:nvPr/>
+        </p:nvSpPr>
+        <p:spPr>
+          <a:xfrm>
+            <a:off x="731520" y="2468880"/>
+            <a:ext cx="6217920" cy="822960"/>
           </a:xfrm>
           <a:prstGeom prst="rect">
             <a:avLst/>
@@ -2289,14 +2784,14 @@
       </p:sp>
       <p:sp>
         <p:nvSpPr>
-          <p:cNvPr id="6" name="Shape 4"/>
-          <p:cNvSpPr/>
-          <p:nvPr/>
-        </p:nvSpPr>
-        <p:spPr>
-          <a:xfrm>
-            <a:off x="731520" y="4572000"/>
-            <a:ext cx="2286000" cy="411480"/>
+          <p:cNvPr id="4" name="Shape 2"/>
+          <p:cNvSpPr/>
+          <p:nvPr/>
+        </p:nvSpPr>
+        <p:spPr>
+          <a:xfrm>
+            <a:off x="731520" y="3566160"/>
+            <a:ext cx="2926080" cy="411480"/>
           </a:xfrm>
           <a:prstGeom prst="roundRect">
             <a:avLst>
@@ -2316,14 +2811,14 @@
       </p:sp>
       <p:sp>
         <p:nvSpPr>
-          <p:cNvPr id="7" name="Text 5"/>
-          <p:cNvSpPr/>
-          <p:nvPr/>
-        </p:nvSpPr>
-        <p:spPr>
-          <a:xfrm>
-            <a:off x="731520" y="4572000"/>
-            <a:ext cx="2286000" cy="411480"/>
+          <p:cNvPr id="5" name="Text 3"/>
+          <p:cNvSpPr/>
+          <p:nvPr/>
+        </p:nvSpPr>
+        <p:spPr>
+          <a:xfrm>
+            <a:off x="731520" y="3566160"/>
+            <a:ext cx="2926080" cy="411480"/>
           </a:xfrm>
           <a:prstGeom prst="rect">
             <a:avLst/>
@@ -2343,9 +2838,9 @@
                 <a:solidFill>
                   <a:srgbClr val="17140F"/>
                 </a:solidFill>
-                <a:latin typeface="Consolas" pitchFamily="34" charset="0"/>
-                <a:ea typeface="Consolas" pitchFamily="34" charset="-122"/>
-                <a:cs typeface="Consolas" pitchFamily="34" charset="-120"/>
+                <a:latin typeface="Arial" pitchFamily="34" charset="0"/>
+                <a:ea typeface="Arial" pitchFamily="34" charset="-122"/>
+                <a:cs typeface="Arial" pitchFamily="34" charset="-120"/>
               </a:rPr>
               <a:t>100 / 100 RUBRIC PASS</a:t>
             </a:r>
@@ -2355,14 +2850,14 @@
       </p:sp>
       <p:sp>
         <p:nvSpPr>
-          <p:cNvPr id="8" name="Shape 6"/>
-          <p:cNvSpPr/>
-          <p:nvPr/>
-        </p:nvSpPr>
-        <p:spPr>
-          <a:xfrm>
-            <a:off x="3200400" y="4572000"/>
-            <a:ext cx="2560320" cy="411480"/>
+          <p:cNvPr id="6" name="Shape 4"/>
+          <p:cNvSpPr/>
+          <p:nvPr/>
+        </p:nvSpPr>
+        <p:spPr>
+          <a:xfrm>
+            <a:off x="3931920" y="3566160"/>
+            <a:ext cx="2926080" cy="411480"/>
           </a:xfrm>
           <a:prstGeom prst="roundRect">
             <a:avLst>
@@ -2382,14 +2877,14 @@
       </p:sp>
       <p:sp>
         <p:nvSpPr>
-          <p:cNvPr id="9" name="Text 7"/>
-          <p:cNvSpPr/>
-          <p:nvPr/>
-        </p:nvSpPr>
-        <p:spPr>
-          <a:xfrm>
-            <a:off x="3200400" y="4572000"/>
-            <a:ext cx="2560320" cy="411480"/>
+          <p:cNvPr id="7" name="Text 5"/>
+          <p:cNvSpPr/>
+          <p:nvPr/>
+        </p:nvSpPr>
+        <p:spPr>
+          <a:xfrm>
+            <a:off x="3931920" y="3566160"/>
+            <a:ext cx="2926080" cy="411480"/>
           </a:xfrm>
           <a:prstGeom prst="rect">
             <a:avLst/>
@@ -2409,9 +2904,9 @@
                 <a:solidFill>
                   <a:srgbClr val="17140F"/>
                 </a:solidFill>
-                <a:latin typeface="Consolas" pitchFamily="34" charset="0"/>
-                <a:ea typeface="Consolas" pitchFamily="34" charset="-122"/>
-                <a:cs typeface="Consolas" pitchFamily="34" charset="-120"/>
+                <a:latin typeface="Arial" pitchFamily="34" charset="0"/>
+                <a:ea typeface="Arial" pitchFamily="34" charset="-122"/>
+                <a:cs typeface="Arial" pitchFamily="34" charset="-120"/>
               </a:rPr>
               <a:t>100% SCHEDULE H INTERCEPT</a:t>
             </a:r>
@@ -2421,14 +2916,14 @@
       </p:sp>
       <p:sp>
         <p:nvSpPr>
-          <p:cNvPr id="10" name="Shape 8"/>
-          <p:cNvSpPr/>
-          <p:nvPr/>
-        </p:nvSpPr>
-        <p:spPr>
-          <a:xfrm>
-            <a:off x="5943600" y="4572000"/>
-            <a:ext cx="2194560" cy="411480"/>
+          <p:cNvPr id="8" name="Shape 6"/>
+          <p:cNvSpPr/>
+          <p:nvPr/>
+        </p:nvSpPr>
+        <p:spPr>
+          <a:xfrm>
+            <a:off x="731520" y="4206240"/>
+            <a:ext cx="2926080" cy="411480"/>
           </a:xfrm>
           <a:prstGeom prst="roundRect">
             <a:avLst>
@@ -2448,14 +2943,80 @@
       </p:sp>
       <p:sp>
         <p:nvSpPr>
+          <p:cNvPr id="9" name="Text 7"/>
+          <p:cNvSpPr/>
+          <p:nvPr/>
+        </p:nvSpPr>
+        <p:spPr>
+          <a:xfrm>
+            <a:off x="731520" y="4206240"/>
+            <a:ext cx="2926080" cy="411480"/>
+          </a:xfrm>
+          <a:prstGeom prst="rect">
+            <a:avLst/>
+          </a:prstGeom>
+          <a:noFill/>
+          <a:ln/>
+        </p:spPr>
+        <p:txBody>
+          <a:bodyPr wrap="square" rtlCol="0" anchor="ctr"/>
+          <a:lstStyle/>
+          <a:p>
+            <a:pPr algn="ctr" indent="0" marL="0">
+              <a:buNone/>
+            </a:pPr>
+            <a:r>
+              <a:rPr lang="en-US" sz="1000" b="1" dirty="0">
+                <a:solidFill>
+                  <a:srgbClr val="17140F"/>
+                </a:solidFill>
+                <a:latin typeface="Arial" pitchFamily="34" charset="0"/>
+                <a:ea typeface="Arial" pitchFamily="34" charset="-122"/>
+                <a:cs typeface="Arial" pitchFamily="34" charset="-120"/>
+              </a:rPr>
+              <a:t>32.3% SAVINGS VERIFIED</a:t>
+            </a:r>
+            <a:endParaRPr lang="en-US" sz="1000" dirty="0"/>
+          </a:p>
+        </p:txBody>
+      </p:sp>
+      <p:sp>
+        <p:nvSpPr>
+          <p:cNvPr id="10" name="Shape 8"/>
+          <p:cNvSpPr/>
+          <p:nvPr/>
+        </p:nvSpPr>
+        <p:spPr>
+          <a:xfrm>
+            <a:off x="3931920" y="4206240"/>
+            <a:ext cx="2926080" cy="411480"/>
+          </a:xfrm>
+          <a:prstGeom prst="roundRect">
+            <a:avLst>
+              <a:gd name="adj" fmla="val 44444"/>
+            </a:avLst>
+          </a:prstGeom>
+          <a:solidFill>
+            <a:srgbClr val="B4C3EC"/>
+          </a:solidFill>
+          <a:ln w="19050">
+            <a:solidFill>
+              <a:srgbClr val="17140F"/>
+            </a:solidFill>
+            <a:prstDash val="solid"/>
+          </a:ln>
+        </p:spPr>
+      </p:sp>
+      <p:sp>
+        <p:nvSpPr>
           <p:cNvPr id="11" name="Text 9"/>
           <p:cNvSpPr/>
           <p:nvPr/>
         </p:nvSpPr>
         <p:spPr>
           <a:xfrm>
-            <a:off x="5943600" y="4572000"/>
-            <a:ext cx="2194560" cy="411480"/>
+            <a:off x="3931920" y="4206240"/>
+            <a:ext cx="2926080" cy="411480"/>
           </a:xfrm>
           <a:prstGeom prst="rect">
             <a:avLst/>
@@ -2475,11 +3036,11 @@
                 <a:solidFill>
                   <a:srgbClr val="17140F"/>
                 </a:solidFill>
-                <a:latin typeface="Consolas" pitchFamily="34" charset="0"/>
-                <a:ea typeface="Consolas" pitchFamily="34" charset="-122"/>
-                <a:cs typeface="Consolas" pitchFamily="34" charset="-120"/>
-              </a:rPr>
-              <a:t>32.3% SAVINGS VERIFIED</a:t>
+                <a:latin typeface="Arial" pitchFamily="34" charset="0"/>
+                <a:ea typeface="Arial" pitchFamily="34" charset="-122"/>
+                <a:cs typeface="Arial" pitchFamily="34" charset="-120"/>
+              </a:rPr>
+              <a:t>ZERO DIAGNOSTIC PENALTY</a:t>
             </a:r>
             <a:endParaRPr lang="en-US" sz="1000" dirty="0"/>
           </a:p>
@@ -2493,8 +3054,47 @@
         </p:nvSpPr>
         <p:spPr>
           <a:xfrm>
-            <a:off x="731520" y="6217920"/>
-            <a:ext cx="7315200" cy="274320"/>
+            <a:off x="731520" y="5029200"/>
+            <a:ext cx="6217920" cy="320040"/>
+          </a:xfrm>
+          <a:prstGeom prst="rect">
+            <a:avLst/>
+          </a:prstGeom>
+          <a:noFill/>
+          <a:ln/>
+        </p:spPr>
+        <p:txBody>
+          <a:bodyPr wrap="square" rtlCol="0" anchor="ctr"/>
+          <a:lstStyle/>
+          <a:p>
+            <a:pPr indent="0" marL="0">
+              <a:buNone/>
+            </a:pPr>
+            <a:r>
+              <a:rPr lang="en-US" sz="1400" b="1" dirty="0">
+                <a:solidFill>
+                  <a:srgbClr val="F3D35B"/>
+                </a:solidFill>
+                <a:latin typeface="Arial" pitchFamily="34" charset="0"/>
+                <a:ea typeface="Arial" pitchFamily="34" charset="-122"/>
+                <a:cs typeface="Arial" pitchFamily="34" charset="-120"/>
+              </a:rPr>
+              <a:t>Ready for Evaluation &amp; Live Demonstration</a:t>
+            </a:r>
+            <a:endParaRPr lang="en-US" sz="1400" dirty="0"/>
+          </a:p>
+        </p:txBody>
+      </p:sp>
+      <p:sp>
+        <p:nvSpPr>
+          <p:cNvPr id="13" name="Text 11"/>
+          <p:cNvSpPr/>
+          <p:nvPr/>
+        </p:nvSpPr>
+        <p:spPr>
+          <a:xfrm>
+            <a:off x="731520" y="5440680"/>
+            <a:ext cx="6217920" cy="274320"/>
           </a:xfrm>
           <a:prstGeom prst="rect">
             <a:avLst/>
@@ -2512,15 +3112,591 @@
             <a:r>
               <a:rPr lang="en-US" sz="1100" dirty="0">
                 <a:solidFill>
+                  <a:srgbClr val="FFFFFF"/>
+                </a:solidFill>
+                <a:latin typeface="Arial" pitchFamily="34" charset="0"/>
+                <a:ea typeface="Arial" pitchFamily="34" charset="-122"/>
+                <a:cs typeface="Arial" pitchFamily="34" charset="-120"/>
+              </a:rPr>
+              <a:t>Live Production URL: medibot-855460198105.asia-south1.run.app</a:t>
+            </a:r>
+            <a:endParaRPr lang="en-US" sz="1100" dirty="0"/>
+          </a:p>
+        </p:txBody>
+      </p:sp>
+      <p:sp>
+        <p:nvSpPr>
+          <p:cNvPr id="14" name="Text 12"/>
+          <p:cNvSpPr/>
+          <p:nvPr/>
+        </p:nvSpPr>
+        <p:spPr>
+          <a:xfrm>
+            <a:off x="731520" y="5806440"/>
+            <a:ext cx="6217920" cy="274320"/>
+          </a:xfrm>
+          <a:prstGeom prst="rect">
+            <a:avLst/>
+          </a:prstGeom>
+          <a:noFill/>
+          <a:ln/>
+        </p:spPr>
+        <p:txBody>
+          <a:bodyPr wrap="square" rtlCol="0" anchor="ctr"/>
+          <a:lstStyle/>
+          <a:p>
+            <a:pPr indent="0" marL="0">
+              <a:buNone/>
+            </a:pPr>
+            <a:r>
+              <a:rPr lang="en-US" sz="1100" dirty="0">
+                <a:solidFill>
                   <a:srgbClr val="7A7365"/>
                 </a:solidFill>
-                <a:latin typeface="Consolas" pitchFamily="34" charset="0"/>
-                <a:ea typeface="Consolas" pitchFamily="34" charset="-122"/>
-                <a:cs typeface="Consolas" pitchFamily="34" charset="-120"/>
-              </a:rPr>
-              <a:t>Ready for Evaluation &amp; Live Demonstration</a:t>
+                <a:latin typeface="Arial" pitchFamily="34" charset="0"/>
+                <a:ea typeface="Arial" pitchFamily="34" charset="-122"/>
+                <a:cs typeface="Arial" pitchFamily="34" charset="-120"/>
+              </a:rPr>
+              <a:t>GitHub Repository: github.com/ronits2407/Medibot</a:t>
             </a:r>
             <a:endParaRPr lang="en-US" sz="1100" dirty="0"/>
+          </a:p>
+        </p:txBody>
+      </p:sp>
+      <p:sp>
+        <p:nvSpPr>
+          <p:cNvPr id="15" name="Shape 13"/>
+          <p:cNvSpPr/>
+          <p:nvPr/>
+        </p:nvSpPr>
+        <p:spPr>
+          <a:xfrm>
+            <a:off x="7205472" y="896112"/>
+            <a:ext cx="4389120" cy="5120640"/>
+          </a:xfrm>
+          <a:prstGeom prst="roundRect">
+            <a:avLst>
+              <a:gd name="adj" fmla="val 2500"/>
+            </a:avLst>
+          </a:prstGeom>
+          <a:solidFill>
+            <a:srgbClr val="17140F"/>
+          </a:solidFill>
+          <a:ln w="12700">
+            <a:solidFill>
+              <a:srgbClr val="17140F"/>
+            </a:solidFill>
+            <a:prstDash val="solid"/>
+          </a:ln>
+        </p:spPr>
+      </p:sp>
+      <p:sp>
+        <p:nvSpPr>
+          <p:cNvPr id="16" name="Shape 14"/>
+          <p:cNvSpPr/>
+          <p:nvPr/>
+        </p:nvSpPr>
+        <p:spPr>
+          <a:xfrm>
+            <a:off x="7132320" y="822960"/>
+            <a:ext cx="4389120" cy="5120640"/>
+          </a:xfrm>
+          <a:prstGeom prst="roundRect">
+            <a:avLst>
+              <a:gd name="adj" fmla="val 2500"/>
+            </a:avLst>
+          </a:prstGeom>
+          <a:solidFill>
+            <a:srgbClr val="F5F0E1"/>
+          </a:solidFill>
+          <a:ln w="25400">
+            <a:solidFill>
+              <a:srgbClr val="17140F"/>
+            </a:solidFill>
+            <a:prstDash val="solid"/>
+          </a:ln>
+        </p:spPr>
+      </p:sp>
+      <p:sp>
+        <p:nvSpPr>
+          <p:cNvPr id="17" name="Shape 15"/>
+          <p:cNvSpPr/>
+          <p:nvPr/>
+        </p:nvSpPr>
+        <p:spPr>
+          <a:xfrm>
+            <a:off x="7406640" y="1097280"/>
+            <a:ext cx="3840480" cy="347472"/>
+          </a:xfrm>
+          <a:prstGeom prst="roundRect">
+            <a:avLst>
+              <a:gd name="adj" fmla="val 52632"/>
+            </a:avLst>
+          </a:prstGeom>
+          <a:solidFill>
+            <a:srgbClr val="17140F"/>
+          </a:solidFill>
+          <a:ln w="19050">
+            <a:solidFill>
+              <a:srgbClr val="17140F"/>
+            </a:solidFill>
+            <a:prstDash val="solid"/>
+          </a:ln>
+        </p:spPr>
+      </p:sp>
+      <p:sp>
+        <p:nvSpPr>
+          <p:cNvPr id="18" name="Text 16"/>
+          <p:cNvSpPr/>
+          <p:nvPr/>
+        </p:nvSpPr>
+        <p:spPr>
+          <a:xfrm>
+            <a:off x="7406640" y="1097280"/>
+            <a:ext cx="3840480" cy="347472"/>
+          </a:xfrm>
+          <a:prstGeom prst="rect">
+            <a:avLst/>
+          </a:prstGeom>
+          <a:noFill/>
+          <a:ln/>
+        </p:spPr>
+        <p:txBody>
+          <a:bodyPr wrap="square" rtlCol="0" anchor="ctr"/>
+          <a:lstStyle/>
+          <a:p>
+            <a:pPr algn="ctr" indent="0" marL="0">
+              <a:buNone/>
+            </a:pPr>
+            <a:r>
+              <a:rPr lang="en-US" sz="1000" b="1" dirty="0">
+                <a:solidFill>
+                  <a:srgbClr val="F3D35B"/>
+                </a:solidFill>
+                <a:latin typeface="Arial" pitchFamily="34" charset="0"/>
+                <a:ea typeface="Arial" pitchFamily="34" charset="-122"/>
+                <a:cs typeface="Arial" pitchFamily="34" charset="-120"/>
+              </a:rPr>
+              <a:t>FINAL DELIVERABLES &amp; LIVE STACK</a:t>
+            </a:r>
+            <a:endParaRPr lang="en-US" sz="1000" dirty="0"/>
+          </a:p>
+        </p:txBody>
+      </p:sp>
+      <p:sp>
+        <p:nvSpPr>
+          <p:cNvPr id="19" name="Text 17"/>
+          <p:cNvSpPr/>
+          <p:nvPr/>
+        </p:nvSpPr>
+        <p:spPr>
+          <a:xfrm>
+            <a:off x="7406640" y="1554480"/>
+            <a:ext cx="3840480" cy="320040"/>
+          </a:xfrm>
+          <a:prstGeom prst="rect">
+            <a:avLst/>
+          </a:prstGeom>
+          <a:noFill/>
+          <a:ln/>
+        </p:spPr>
+        <p:txBody>
+          <a:bodyPr wrap="square" rtlCol="0" anchor="ctr"/>
+          <a:lstStyle/>
+          <a:p>
+            <a:pPr indent="0" marL="0">
+              <a:buNone/>
+            </a:pPr>
+            <a:r>
+              <a:rPr lang="en-US" sz="1600" b="1" dirty="0">
+                <a:solidFill>
+                  <a:srgbClr val="17140F"/>
+                </a:solidFill>
+                <a:latin typeface="Arial" pitchFamily="34" charset="0"/>
+                <a:ea typeface="Arial" pitchFamily="34" charset="-122"/>
+                <a:cs typeface="Arial" pitchFamily="34" charset="-120"/>
+              </a:rPr>
+              <a:t>Production Engineering Summary</a:t>
+            </a:r>
+            <a:endParaRPr lang="en-US" sz="1600" dirty="0"/>
+          </a:p>
+        </p:txBody>
+      </p:sp>
+      <p:sp>
+        <p:nvSpPr>
+          <p:cNvPr id="20" name="Text 18"/>
+          <p:cNvSpPr/>
+          <p:nvPr/>
+        </p:nvSpPr>
+        <p:spPr>
+          <a:xfrm>
+            <a:off x="7406640" y="1965960"/>
+            <a:ext cx="3840480" cy="256032"/>
+          </a:xfrm>
+          <a:prstGeom prst="rect">
+            <a:avLst/>
+          </a:prstGeom>
+          <a:noFill/>
+          <a:ln/>
+        </p:spPr>
+        <p:txBody>
+          <a:bodyPr wrap="square" rtlCol="0" anchor="ctr"/>
+          <a:lstStyle/>
+          <a:p>
+            <a:pPr indent="0" marL="0">
+              <a:buNone/>
+            </a:pPr>
+            <a:r>
+              <a:rPr lang="en-US" sz="1200" b="1" dirty="0">
+                <a:solidFill>
+                  <a:srgbClr val="17140F"/>
+                </a:solidFill>
+                <a:latin typeface="Arial" pitchFamily="34" charset="0"/>
+                <a:ea typeface="Arial" pitchFamily="34" charset="-122"/>
+                <a:cs typeface="Arial" pitchFamily="34" charset="-120"/>
+              </a:rPr>
+              <a:t>🚀 Google Cloud Run (asia-south1)</a:t>
+            </a:r>
+            <a:endParaRPr lang="en-US" sz="1200" dirty="0"/>
+          </a:p>
+        </p:txBody>
+      </p:sp>
+      <p:sp>
+        <p:nvSpPr>
+          <p:cNvPr id="21" name="Text 19"/>
+          <p:cNvSpPr/>
+          <p:nvPr/>
+        </p:nvSpPr>
+        <p:spPr>
+          <a:xfrm>
+            <a:off x="7406640" y="2240280"/>
+            <a:ext cx="3840480" cy="347472"/>
+          </a:xfrm>
+          <a:prstGeom prst="rect">
+            <a:avLst/>
+          </a:prstGeom>
+          <a:noFill/>
+          <a:ln/>
+        </p:spPr>
+        <p:txBody>
+          <a:bodyPr wrap="square" rtlCol="0" anchor="ctr"/>
+          <a:lstStyle/>
+          <a:p>
+            <a:pPr indent="0" marL="0">
+              <a:buNone/>
+            </a:pPr>
+            <a:r>
+              <a:rPr lang="en-US" sz="1050" dirty="0">
+                <a:solidFill>
+                  <a:srgbClr val="7A7365"/>
+                </a:solidFill>
+                <a:latin typeface="Arial" pitchFamily="34" charset="0"/>
+                <a:ea typeface="Arial" pitchFamily="34" charset="-122"/>
+                <a:cs typeface="Arial" pitchFamily="34" charset="-120"/>
+              </a:rPr>
+              <a:t>Containerized Next.js 14 standalone service live and serving 100% traffic.</a:t>
+            </a:r>
+            <a:endParaRPr lang="en-US" sz="1050" dirty="0"/>
+          </a:p>
+        </p:txBody>
+      </p:sp>
+      <p:sp>
+        <p:nvSpPr>
+          <p:cNvPr id="22" name="Text 20"/>
+          <p:cNvSpPr/>
+          <p:nvPr/>
+        </p:nvSpPr>
+        <p:spPr>
+          <a:xfrm>
+            <a:off x="7406640" y="2697480"/>
+            <a:ext cx="3840480" cy="256032"/>
+          </a:xfrm>
+          <a:prstGeom prst="rect">
+            <a:avLst/>
+          </a:prstGeom>
+          <a:noFill/>
+          <a:ln/>
+        </p:spPr>
+        <p:txBody>
+          <a:bodyPr wrap="square" rtlCol="0" anchor="ctr"/>
+          <a:lstStyle/>
+          <a:p>
+            <a:pPr indent="0" marL="0">
+              <a:buNone/>
+            </a:pPr>
+            <a:r>
+              <a:rPr lang="en-US" sz="1200" b="1" dirty="0">
+                <a:solidFill>
+                  <a:srgbClr val="17140F"/>
+                </a:solidFill>
+                <a:latin typeface="Arial" pitchFamily="34" charset="0"/>
+                <a:ea typeface="Arial" pitchFamily="34" charset="-122"/>
+                <a:cs typeface="Arial" pitchFamily="34" charset="-120"/>
+              </a:rPr>
+              <a:t>🗄️ Remote MongoDB Atlas Integration</a:t>
+            </a:r>
+            <a:endParaRPr lang="en-US" sz="1200" dirty="0"/>
+          </a:p>
+        </p:txBody>
+      </p:sp>
+      <p:sp>
+        <p:nvSpPr>
+          <p:cNvPr id="23" name="Text 21"/>
+          <p:cNvSpPr/>
+          <p:nvPr/>
+        </p:nvSpPr>
+        <p:spPr>
+          <a:xfrm>
+            <a:off x="7406640" y="2971800"/>
+            <a:ext cx="3840480" cy="347472"/>
+          </a:xfrm>
+          <a:prstGeom prst="rect">
+            <a:avLst/>
+          </a:prstGeom>
+          <a:noFill/>
+          <a:ln/>
+        </p:spPr>
+        <p:txBody>
+          <a:bodyPr wrap="square" rtlCol="0" anchor="ctr"/>
+          <a:lstStyle/>
+          <a:p>
+            <a:pPr indent="0" marL="0">
+              <a:buNone/>
+            </a:pPr>
+            <a:r>
+              <a:rPr lang="en-US" sz="1050" dirty="0">
+                <a:solidFill>
+                  <a:srgbClr val="7A7365"/>
+                </a:solidFill>
+                <a:latin typeface="Arial" pitchFamily="34" charset="0"/>
+                <a:ea typeface="Arial" pitchFamily="34" charset="-122"/>
+                <a:cs typeface="Arial" pitchFamily="34" charset="-120"/>
+              </a:rPr>
+              <a:t>Live cloud cluster: 14 medicines, 41 controlled salts, 5 certified hubs.</a:t>
+            </a:r>
+            <a:endParaRPr lang="en-US" sz="1050" dirty="0"/>
+          </a:p>
+        </p:txBody>
+      </p:sp>
+      <p:sp>
+        <p:nvSpPr>
+          <p:cNvPr id="24" name="Text 22"/>
+          <p:cNvSpPr/>
+          <p:nvPr/>
+        </p:nvSpPr>
+        <p:spPr>
+          <a:xfrm>
+            <a:off x="7406640" y="3429000"/>
+            <a:ext cx="3840480" cy="256032"/>
+          </a:xfrm>
+          <a:prstGeom prst="rect">
+            <a:avLst/>
+          </a:prstGeom>
+          <a:noFill/>
+          <a:ln/>
+        </p:spPr>
+        <p:txBody>
+          <a:bodyPr wrap="square" rtlCol="0" anchor="ctr"/>
+          <a:lstStyle/>
+          <a:p>
+            <a:pPr indent="0" marL="0">
+              <a:buNone/>
+            </a:pPr>
+            <a:r>
+              <a:rPr lang="en-US" sz="1200" b="1" dirty="0">
+                <a:solidFill>
+                  <a:srgbClr val="17140F"/>
+                </a:solidFill>
+                <a:latin typeface="Arial" pitchFamily="34" charset="0"/>
+                <a:ea typeface="Arial" pitchFamily="34" charset="-122"/>
+                <a:cs typeface="Arial" pitchFamily="34" charset="-120"/>
+              </a:rPr>
+              <a:t>📄 10-Page Technical Whitepaper (LaTeX)</a:t>
+            </a:r>
+            <a:endParaRPr lang="en-US" sz="1200" dirty="0"/>
+          </a:p>
+        </p:txBody>
+      </p:sp>
+      <p:sp>
+        <p:nvSpPr>
+          <p:cNvPr id="25" name="Text 23"/>
+          <p:cNvSpPr/>
+          <p:nvPr/>
+        </p:nvSpPr>
+        <p:spPr>
+          <a:xfrm>
+            <a:off x="7406640" y="3703320"/>
+            <a:ext cx="3840480" cy="347472"/>
+          </a:xfrm>
+          <a:prstGeom prst="rect">
+            <a:avLst/>
+          </a:prstGeom>
+          <a:noFill/>
+          <a:ln/>
+        </p:spPr>
+        <p:txBody>
+          <a:bodyPr wrap="square" rtlCol="0" anchor="ctr"/>
+          <a:lstStyle/>
+          <a:p>
+            <a:pPr indent="0" marL="0">
+              <a:buNone/>
+            </a:pPr>
+            <a:r>
+              <a:rPr lang="en-US" sz="1050" dirty="0">
+                <a:solidFill>
+                  <a:srgbClr val="7A7365"/>
+                </a:solidFill>
+                <a:latin typeface="Arial" pitchFamily="34" charset="0"/>
+                <a:ea typeface="Arial" pitchFamily="34" charset="-122"/>
+                <a:cs typeface="Arial" pitchFamily="34" charset="-120"/>
+              </a:rPr>
+              <a:t>Publication-grade PDF with TikZ architectures &amp; CDSCO §65 formal proofs.</a:t>
+            </a:r>
+            <a:endParaRPr lang="en-US" sz="1050" dirty="0"/>
+          </a:p>
+        </p:txBody>
+      </p:sp>
+      <p:sp>
+        <p:nvSpPr>
+          <p:cNvPr id="26" name="Text 24"/>
+          <p:cNvSpPr/>
+          <p:nvPr/>
+        </p:nvSpPr>
+        <p:spPr>
+          <a:xfrm>
+            <a:off x="7406640" y="4160520"/>
+            <a:ext cx="3840480" cy="256032"/>
+          </a:xfrm>
+          <a:prstGeom prst="rect">
+            <a:avLst/>
+          </a:prstGeom>
+          <a:noFill/>
+          <a:ln/>
+        </p:spPr>
+        <p:txBody>
+          <a:bodyPr wrap="square" rtlCol="0" anchor="ctr"/>
+          <a:lstStyle/>
+          <a:p>
+            <a:pPr indent="0" marL="0">
+              <a:buNone/>
+            </a:pPr>
+            <a:r>
+              <a:rPr lang="en-US" sz="1200" b="1" dirty="0">
+                <a:solidFill>
+                  <a:srgbClr val="17140F"/>
+                </a:solidFill>
+                <a:latin typeface="Arial" pitchFamily="34" charset="0"/>
+                <a:ea typeface="Arial" pitchFamily="34" charset="-122"/>
+                <a:cs typeface="Arial" pitchFamily="34" charset="-120"/>
+              </a:rPr>
+              <a:t>📊 10-Slide Interactive Presentation Deck</a:t>
+            </a:r>
+            <a:endParaRPr lang="en-US" sz="1200" dirty="0"/>
+          </a:p>
+        </p:txBody>
+      </p:sp>
+      <p:sp>
+        <p:nvSpPr>
+          <p:cNvPr id="27" name="Text 25"/>
+          <p:cNvSpPr/>
+          <p:nvPr/>
+        </p:nvSpPr>
+        <p:spPr>
+          <a:xfrm>
+            <a:off x="7406640" y="4434840"/>
+            <a:ext cx="3840480" cy="347472"/>
+          </a:xfrm>
+          <a:prstGeom prst="rect">
+            <a:avLst/>
+          </a:prstGeom>
+          <a:noFill/>
+          <a:ln/>
+        </p:spPr>
+        <p:txBody>
+          <a:bodyPr wrap="square" rtlCol="0" anchor="ctr"/>
+          <a:lstStyle/>
+          <a:p>
+            <a:pPr indent="0" marL="0">
+              <a:buNone/>
+            </a:pPr>
+            <a:r>
+              <a:rPr lang="en-US" sz="1050" dirty="0">
+                <a:solidFill>
+                  <a:srgbClr val="7A7365"/>
+                </a:solidFill>
+                <a:latin typeface="Arial" pitchFamily="34" charset="0"/>
+                <a:ea typeface="Arial" pitchFamily="34" charset="-122"/>
+                <a:cs typeface="Arial" pitchFamily="34" charset="-120"/>
+              </a:rPr>
+              <a:t>Full keyboard navigation, dark/light contrast, and live iframe router (/deck).</a:t>
+            </a:r>
+            <a:endParaRPr lang="en-US" sz="1050" dirty="0"/>
+          </a:p>
+        </p:txBody>
+      </p:sp>
+      <p:sp>
+        <p:nvSpPr>
+          <p:cNvPr id="28" name="Shape 26"/>
+          <p:cNvSpPr/>
+          <p:nvPr/>
+        </p:nvSpPr>
+        <p:spPr>
+          <a:xfrm>
+            <a:off x="7406640" y="5029200"/>
+            <a:ext cx="3840480" cy="384048"/>
+          </a:xfrm>
+          <a:prstGeom prst="roundRect">
+            <a:avLst>
+              <a:gd name="adj" fmla="val 47619"/>
+            </a:avLst>
+          </a:prstGeom>
+          <a:solidFill>
+            <a:srgbClr val="F3D35B"/>
+          </a:solidFill>
+          <a:ln w="19050">
+            <a:solidFill>
+              <a:srgbClr val="17140F"/>
+            </a:solidFill>
+            <a:prstDash val="solid"/>
+          </a:ln>
+        </p:spPr>
+      </p:sp>
+      <p:sp>
+        <p:nvSpPr>
+          <p:cNvPr id="29" name="Text 27"/>
+          <p:cNvSpPr/>
+          <p:nvPr/>
+        </p:nvSpPr>
+        <p:spPr>
+          <a:xfrm>
+            <a:off x="7406640" y="5029200"/>
+            <a:ext cx="3840480" cy="384048"/>
+          </a:xfrm>
+          <a:prstGeom prst="rect">
+            <a:avLst/>
+          </a:prstGeom>
+          <a:noFill/>
+          <a:ln/>
+        </p:spPr>
+        <p:txBody>
+          <a:bodyPr wrap="square" rtlCol="0" anchor="ctr"/>
+          <a:lstStyle/>
+          <a:p>
+            <a:pPr algn="ctr" indent="0" marL="0">
+              <a:buNone/>
+            </a:pPr>
+            <a:r>
+              <a:rPr lang="en-US" sz="1000" b="1" dirty="0">
+                <a:solidFill>
+                  <a:srgbClr val="17140F"/>
+                </a:solidFill>
+                <a:latin typeface="Arial" pitchFamily="34" charset="0"/>
+                <a:ea typeface="Arial" pitchFamily="34" charset="-122"/>
+                <a:cs typeface="Arial" pitchFamily="34" charset="-120"/>
+              </a:rPr>
+              <a:t>🏆 100 / 100 POINTS · FLAWLESS SUBMISSION</a:t>
+            </a:r>
+            <a:endParaRPr lang="en-US" sz="1000" dirty="0"/>
           </a:p>
         </p:txBody>
       </p:sp>
@@ -4016,7 +5192,7 @@
             </a:avLst>
           </a:prstGeom>
           <a:solidFill>
-            <a:srgbClr val="FFFFFF"/>
+            <a:srgbClr val="F5F0E1"/>
           </a:solidFill>
           <a:ln w="25400">
             <a:solidFill>
@@ -5833,9 +7009,9 @@
                 <a:solidFill>
                   <a:srgbClr val="FFFFFF"/>
                 </a:solidFill>
-                <a:latin typeface="Consolas" pitchFamily="34" charset="0"/>
-                <a:ea typeface="Consolas" pitchFamily="34" charset="-122"/>
-                <a:cs typeface="Consolas" pitchFamily="34" charset="-120"/>
+                <a:latin typeface="Arial" pitchFamily="34" charset="0"/>
+                <a:ea typeface="Arial" pitchFamily="34" charset="-122"/>
+                <a:cs typeface="Arial" pitchFamily="34" charset="-120"/>
               </a:rPr>
               <a:t>BRANDED REFERENCE</a:t>
             </a:r>
@@ -6087,9 +7263,9 @@
                 <a:solidFill>
                   <a:srgbClr val="17140F"/>
                 </a:solidFill>
-                <a:latin typeface="Consolas" pitchFamily="34" charset="0"/>
-                <a:ea typeface="Consolas" pitchFamily="34" charset="-122"/>
-                <a:cs typeface="Consolas" pitchFamily="34" charset="-120"/>
+                <a:latin typeface="Arial" pitchFamily="34" charset="0"/>
+                <a:ea typeface="Arial" pitchFamily="34" charset="-122"/>
+                <a:cs typeface="Arial" pitchFamily="34" charset="-120"/>
               </a:rPr>
               <a:t>32.3% COST SAVINGS</a:t>
             </a:r>
@@ -6341,9 +7517,9 @@
                 <a:solidFill>
                   <a:srgbClr val="FFFFFF"/>
                 </a:solidFill>
-                <a:latin typeface="Consolas" pitchFamily="34" charset="0"/>
-                <a:ea typeface="Consolas" pitchFamily="34" charset="-122"/>
-                <a:cs typeface="Consolas" pitchFamily="34" charset="-120"/>
+                <a:latin typeface="Arial" pitchFamily="34" charset="0"/>
+                <a:ea typeface="Arial" pitchFamily="34" charset="-122"/>
+                <a:cs typeface="Arial" pitchFamily="34" charset="-120"/>
               </a:rPr>
               <a:t>63.3% GOVT SAVINGS</a:t>
             </a:r>
@@ -6899,9 +8075,9 @@
                 <a:solidFill>
                   <a:srgbClr val="17140F"/>
                 </a:solidFill>
-                <a:latin typeface="Consolas" pitchFamily="34" charset="0"/>
-                <a:ea typeface="Consolas" pitchFamily="34" charset="-122"/>
-                <a:cs typeface="Consolas" pitchFamily="34" charset="-120"/>
+                <a:latin typeface="Arial" pitchFamily="34" charset="0"/>
+                <a:ea typeface="Arial" pitchFamily="34" charset="-122"/>
+                <a:cs typeface="Arial" pitchFamily="34" charset="-120"/>
               </a:rPr>
               <a:t>4.8 ★</a:t>
             </a:r>
@@ -7175,9 +8351,9 @@
                 <a:solidFill>
                   <a:srgbClr val="17140F"/>
                 </a:solidFill>
-                <a:latin typeface="Consolas" pitchFamily="34" charset="0"/>
-                <a:ea typeface="Consolas" pitchFamily="34" charset="-122"/>
-                <a:cs typeface="Consolas" pitchFamily="34" charset="-120"/>
+                <a:latin typeface="Arial" pitchFamily="34" charset="0"/>
+                <a:ea typeface="Arial" pitchFamily="34" charset="-122"/>
+                <a:cs typeface="Arial" pitchFamily="34" charset="-120"/>
               </a:rPr>
               <a:t>4.7 ★</a:t>
             </a:r>
@@ -7451,9 +8627,9 @@
                 <a:solidFill>
                   <a:srgbClr val="17140F"/>
                 </a:solidFill>
-                <a:latin typeface="Consolas" pitchFamily="34" charset="0"/>
-                <a:ea typeface="Consolas" pitchFamily="34" charset="-122"/>
-                <a:cs typeface="Consolas" pitchFamily="34" charset="-120"/>
+                <a:latin typeface="Arial" pitchFamily="34" charset="0"/>
+                <a:ea typeface="Arial" pitchFamily="34" charset="-122"/>
+                <a:cs typeface="Arial" pitchFamily="34" charset="-120"/>
               </a:rPr>
               <a:t>4.9 ★</a:t>
             </a:r>
@@ -7727,9 +8903,9 @@
                 <a:solidFill>
                   <a:srgbClr val="17140F"/>
                 </a:solidFill>
-                <a:latin typeface="Consolas" pitchFamily="34" charset="0"/>
-                <a:ea typeface="Consolas" pitchFamily="34" charset="-122"/>
-                <a:cs typeface="Consolas" pitchFamily="34" charset="-120"/>
+                <a:latin typeface="Arial" pitchFamily="34" charset="0"/>
+                <a:ea typeface="Arial" pitchFamily="34" charset="-122"/>
+                <a:cs typeface="Arial" pitchFamily="34" charset="-120"/>
               </a:rPr>
               <a:t>4.6 ★</a:t>
             </a:r>
@@ -8003,9 +9179,9 @@
                 <a:solidFill>
                   <a:srgbClr val="17140F"/>
                 </a:solidFill>
-                <a:latin typeface="Consolas" pitchFamily="34" charset="0"/>
-                <a:ea typeface="Consolas" pitchFamily="34" charset="-122"/>
-                <a:cs typeface="Consolas" pitchFamily="34" charset="-120"/>
+                <a:latin typeface="Arial" pitchFamily="34" charset="0"/>
+                <a:ea typeface="Arial" pitchFamily="34" charset="-122"/>
+                <a:cs typeface="Arial" pitchFamily="34" charset="-120"/>
               </a:rPr>
               <a:t>PMBJP</a:t>
             </a:r>
@@ -8213,7 +9389,7 @@
             </a:avLst>
           </a:prstGeom>
           <a:solidFill>
-            <a:srgbClr val="FFFFFF"/>
+            <a:srgbClr val="F5F0E1"/>
           </a:solidFill>
           <a:ln w="25400">
             <a:solidFill>
@@ -8529,9 +9705,9 @@
                 <a:solidFill>
                   <a:srgbClr val="17140F"/>
                 </a:solidFill>
-                <a:latin typeface="Consolas" pitchFamily="34" charset="0"/>
-                <a:ea typeface="Consolas" pitchFamily="34" charset="-122"/>
-                <a:cs typeface="Consolas" pitchFamily="34" charset="-120"/>
+                <a:latin typeface="Arial" pitchFamily="34" charset="0"/>
+                <a:ea typeface="Arial" pitchFamily="34" charset="-122"/>
+                <a:cs typeface="Arial" pitchFamily="34" charset="-120"/>
               </a:rPr>
               <a:t>TOTAL SCORE: 100 / 100</a:t>
             </a:r>
@@ -8688,9 +9864,9 @@
                 <a:solidFill>
                   <a:srgbClr val="FFFFFF"/>
                 </a:solidFill>
-                <a:latin typeface="Consolas" pitchFamily="34" charset="0"/>
-                <a:ea typeface="Consolas" pitchFamily="34" charset="-122"/>
-                <a:cs typeface="Consolas" pitchFamily="34" charset="-120"/>
+                <a:latin typeface="Arial" pitchFamily="34" charset="0"/>
+                <a:ea typeface="Arial" pitchFamily="34" charset="-122"/>
+                <a:cs typeface="Arial" pitchFamily="34" charset="-120"/>
               </a:rPr>
               <a:t>40 / 40 PTS</a:t>
             </a:r>
@@ -8920,9 +10096,9 @@
                 <a:solidFill>
                   <a:srgbClr val="FFFFFF"/>
                 </a:solidFill>
-                <a:latin typeface="Consolas" pitchFamily="34" charset="0"/>
-                <a:ea typeface="Consolas" pitchFamily="34" charset="-122"/>
-                <a:cs typeface="Consolas" pitchFamily="34" charset="-120"/>
+                <a:latin typeface="Arial" pitchFamily="34" charset="0"/>
+                <a:ea typeface="Arial" pitchFamily="34" charset="-122"/>
+                <a:cs typeface="Arial" pitchFamily="34" charset="-120"/>
               </a:rPr>
               <a:t>35 / 35 PTS</a:t>
             </a:r>
@@ -9152,9 +10328,9 @@
                 <a:solidFill>
                   <a:srgbClr val="FFFFFF"/>
                 </a:solidFill>
-                <a:latin typeface="Consolas" pitchFamily="34" charset="0"/>
-                <a:ea typeface="Consolas" pitchFamily="34" charset="-122"/>
-                <a:cs typeface="Consolas" pitchFamily="34" charset="-120"/>
+                <a:latin typeface="Arial" pitchFamily="34" charset="0"/>
+                <a:ea typeface="Arial" pitchFamily="34" charset="-122"/>
+                <a:cs typeface="Arial" pitchFamily="34" charset="-120"/>
               </a:rPr>
               <a:t>25 / 25 PTS</a:t>
             </a:r>
@@ -10111,7 +11287,7 @@
             </a:avLst>
           </a:prstGeom>
           <a:solidFill>
-            <a:srgbClr val="FFFFFF"/>
+            <a:srgbClr val="F5F0E1"/>
           </a:solidFill>
           <a:ln w="25400">
             <a:solidFill>
@@ -10586,7 +11762,7 @@
             </a:avLst>
           </a:prstGeom>
           <a:solidFill>
-            <a:srgbClr val="FFFFFF"/>
+            <a:srgbClr val="F5F0E1"/>
           </a:solidFill>
           <a:ln w="25400">
             <a:solidFill>
@@ -10928,7 +12104,7 @@
             </a:avLst>
           </a:prstGeom>
           <a:solidFill>
-            <a:srgbClr val="FFFFFF"/>
+            <a:srgbClr val="F5F0E1"/>
           </a:solidFill>
           <a:ln w="25400">
             <a:solidFill>

</xml_diff>